<commit_message>
v3.53.2: the six audited sources, drawn out
Figure 4 draws the per-source label precision the funnel compresses to "one
of six": 1.000, 0.737, 0.650, 0.578, 0.452, 0.184 against a 0.90 bar. The
same probe reads 1.000 on human-labelled CottonWeedDet12, so the low scores
are the data and not the instrument -- which is the part that makes the gate
an audit result rather than a threshold picked afterwards.

The two horizontal-bar figures anchor their panel letter to the figure
rather than the axes: their y labels own the left third of the canvas, so a
letter placed against the axes rendered as centred.

Co-Authored-By: Claude Opus 5 (1M context) <noreply@anthropic.com>
Claude-Session: https://claude.ai/code/session_019GW1g5v3nTp9QATBzJYkkw
</commit_message>
<xml_diff>
--- a/docs/poster/MTSU_WeedAgent_Poster.pptx
+++ b/docs/poster/MTSU_WeedAgent_Poster.pptx
@@ -3877,15 +3877,39 @@
           </a:p>
         </p:txBody>
       </p:sp>
-      <p:sp>
-        <p:nvSpPr>
-          <p:cNvPr id="21" name="TextBox 20"/>
-          <p:cNvSpPr txBox="1"/>
-          <p:nvPr/>
-        </p:nvSpPr>
-        <p:spPr>
-          <a:xfrm>
-            <a:off x="731520" y="22512689"/>
+      <p:pic>
+        <p:nvPicPr>
+          <p:cNvPr id="21" name="Picture 20" descr="s_sources.png"/>
+          <p:cNvPicPr>
+            <a:picLocks noChangeAspect="1"/>
+          </p:cNvPicPr>
+          <p:nvPr/>
+        </p:nvPicPr>
+        <p:blipFill>
+          <a:blip r:embed="rId5"/>
+          <a:stretch>
+            <a:fillRect/>
+          </a:stretch>
+        </p:blipFill>
+        <p:spPr>
+          <a:xfrm>
+            <a:off x="731520" y="22466969"/>
+            <a:ext cx="10607040" cy="4125268"/>
+          </a:xfrm>
+          <a:prstGeom prst="rect">
+            <a:avLst/>
+          </a:prstGeom>
+        </p:spPr>
+      </p:pic>
+      <p:sp>
+        <p:nvSpPr>
+          <p:cNvPr id="22" name="TextBox 21"/>
+          <p:cNvSpPr txBox="1"/>
+          <p:nvPr/>
+        </p:nvSpPr>
+        <p:spPr>
+          <a:xfrm>
+            <a:off x="731520" y="26683677"/>
             <a:ext cx="10607040" cy="365760"/>
           </a:xfrm>
           <a:prstGeom prst="rect">
@@ -3901,6 +3925,48 @@
           <a:p>
             <a:pPr algn="l">
               <a:lnSpc>
+                <a:spcPct val="120000"/>
+              </a:lnSpc>
+              <a:spcAft>
+                <a:spcPts val="0"/>
+              </a:spcAft>
+            </a:pPr>
+            <a:r>
+              <a:rPr sz="1200" b="0">
+                <a:solidFill>
+                  <a:srgbClr val="556575"/>
+                </a:solidFill>
+                <a:latin typeface="Arial"/>
+              </a:rPr>
+              <a:t>Figure 4.  The six audited harvested sources. The same probe reads 1.000 on human-labelled CottonWeedDet12, so a source at 0.184 is the data and not the instrument. Only the source at the top clears the bar, and it supplies 3,208 of the 13,527 audited images.</a:t>
+            </a:r>
+          </a:p>
+        </p:txBody>
+      </p:sp>
+      <p:sp>
+        <p:nvSpPr>
+          <p:cNvPr id="23" name="TextBox 22"/>
+          <p:cNvSpPr txBox="1"/>
+          <p:nvPr/>
+        </p:nvSpPr>
+        <p:spPr>
+          <a:xfrm>
+            <a:off x="731520" y="27369477"/>
+            <a:ext cx="10607040" cy="365760"/>
+          </a:xfrm>
+          <a:prstGeom prst="rect">
+            <a:avLst/>
+          </a:prstGeom>
+          <a:noFill/>
+        </p:spPr>
+        <p:txBody>
+          <a:bodyPr wrap="square" lIns="0" rIns="0" tIns="0" bIns="0">
+            <a:spAutoFit/>
+          </a:bodyPr>
+          <a:lstStyle/>
+          <a:p>
+            <a:pPr algn="l">
+              <a:lnSpc>
                 <a:spcPct val="95000"/>
               </a:lnSpc>
               <a:spcAft>
@@ -3921,13 +3987,13 @@
       </p:sp>
       <p:sp>
         <p:nvSpPr>
-          <p:cNvPr id="22" name="Rectangle 21"/>
+          <p:cNvPr id="24" name="Rectangle 23"/>
           <p:cNvSpPr/>
           <p:nvPr/>
         </p:nvSpPr>
         <p:spPr>
           <a:xfrm>
-            <a:off x="731520" y="22988177"/>
+            <a:off x="731520" y="27844965"/>
             <a:ext cx="10607040" cy="25603"/>
           </a:xfrm>
           <a:prstGeom prst="rect">
@@ -3965,13 +4031,13 @@
       </p:sp>
       <p:sp>
         <p:nvSpPr>
-          <p:cNvPr id="23" name="TextBox 22"/>
-          <p:cNvSpPr txBox="1"/>
-          <p:nvPr/>
-        </p:nvSpPr>
-        <p:spPr>
-          <a:xfrm>
-            <a:off x="731520" y="23244209"/>
+          <p:cNvPr id="25" name="TextBox 24"/>
+          <p:cNvSpPr txBox="1"/>
+          <p:nvPr/>
+        </p:nvSpPr>
+        <p:spPr>
+          <a:xfrm>
+            <a:off x="731520" y="28100997"/>
             <a:ext cx="10607040" cy="365760"/>
           </a:xfrm>
           <a:prstGeom prst="rect">
@@ -4007,13 +4073,13 @@
       </p:sp>
       <p:sp>
         <p:nvSpPr>
-          <p:cNvPr id="24" name="TextBox 23"/>
-          <p:cNvSpPr txBox="1"/>
-          <p:nvPr/>
-        </p:nvSpPr>
-        <p:spPr>
-          <a:xfrm>
-            <a:off x="731520" y="24207885"/>
+          <p:cNvPr id="26" name="TextBox 25"/>
+          <p:cNvSpPr txBox="1"/>
+          <p:nvPr/>
+        </p:nvSpPr>
+        <p:spPr>
+          <a:xfrm>
+            <a:off x="731520" y="29064673"/>
             <a:ext cx="10607040" cy="365760"/>
           </a:xfrm>
           <a:prstGeom prst="rect">
@@ -4049,13 +4115,13 @@
       </p:sp>
       <p:sp>
         <p:nvSpPr>
-          <p:cNvPr id="25" name="TextBox 24"/>
-          <p:cNvSpPr txBox="1"/>
-          <p:nvPr/>
-        </p:nvSpPr>
-        <p:spPr>
-          <a:xfrm>
-            <a:off x="731520" y="24813675"/>
+          <p:cNvPr id="27" name="TextBox 26"/>
+          <p:cNvSpPr txBox="1"/>
+          <p:nvPr/>
+        </p:nvSpPr>
+        <p:spPr>
+          <a:xfrm>
+            <a:off x="731520" y="29670463"/>
             <a:ext cx="10607040" cy="365760"/>
           </a:xfrm>
           <a:prstGeom prst="rect">
@@ -4091,13 +4157,13 @@
       </p:sp>
       <p:sp>
         <p:nvSpPr>
-          <p:cNvPr id="26" name="Rectangle 25"/>
+          <p:cNvPr id="28" name="Rectangle 27"/>
           <p:cNvSpPr/>
           <p:nvPr/>
         </p:nvSpPr>
         <p:spPr>
           <a:xfrm>
-            <a:off x="731520" y="25289163"/>
+            <a:off x="731520" y="30145951"/>
             <a:ext cx="10607040" cy="25603"/>
           </a:xfrm>
           <a:prstGeom prst="rect">
@@ -4135,13 +4201,13 @@
       </p:sp>
       <p:sp>
         <p:nvSpPr>
-          <p:cNvPr id="27" name="TextBox 26"/>
-          <p:cNvSpPr txBox="1"/>
-          <p:nvPr/>
-        </p:nvSpPr>
-        <p:spPr>
-          <a:xfrm>
-            <a:off x="731520" y="25545195"/>
+          <p:cNvPr id="29" name="TextBox 28"/>
+          <p:cNvSpPr txBox="1"/>
+          <p:nvPr/>
+        </p:nvSpPr>
+        <p:spPr>
+          <a:xfrm>
+            <a:off x="731520" y="30401983"/>
             <a:ext cx="10607040" cy="365760"/>
           </a:xfrm>
           <a:prstGeom prst="rect">
@@ -4177,13 +4243,13 @@
       </p:sp>
       <p:sp>
         <p:nvSpPr>
-          <p:cNvPr id="28" name="Rectangle 27"/>
+          <p:cNvPr id="30" name="Rectangle 29"/>
           <p:cNvSpPr/>
           <p:nvPr/>
         </p:nvSpPr>
         <p:spPr>
           <a:xfrm>
-            <a:off x="731520" y="26090533"/>
+            <a:off x="731520" y="30947321"/>
             <a:ext cx="10607040" cy="20116"/>
           </a:xfrm>
           <a:prstGeom prst="rect">
@@ -4221,13 +4287,13 @@
       </p:sp>
       <p:sp>
         <p:nvSpPr>
-          <p:cNvPr id="29" name="TextBox 28"/>
-          <p:cNvSpPr txBox="1"/>
-          <p:nvPr/>
-        </p:nvSpPr>
-        <p:spPr>
-          <a:xfrm>
-            <a:off x="731520" y="26181973"/>
+          <p:cNvPr id="31" name="TextBox 30"/>
+          <p:cNvSpPr txBox="1"/>
+          <p:nvPr/>
+        </p:nvSpPr>
+        <p:spPr>
+          <a:xfrm>
+            <a:off x="731520" y="31038761"/>
             <a:ext cx="6576364" cy="365760"/>
           </a:xfrm>
           <a:prstGeom prst="rect">
@@ -4263,13 +4329,13 @@
       </p:sp>
       <p:sp>
         <p:nvSpPr>
-          <p:cNvPr id="30" name="TextBox 29"/>
-          <p:cNvSpPr txBox="1"/>
-          <p:nvPr/>
-        </p:nvSpPr>
-        <p:spPr>
-          <a:xfrm>
-            <a:off x="7307884" y="26181973"/>
+          <p:cNvPr id="32" name="TextBox 31"/>
+          <p:cNvSpPr txBox="1"/>
+          <p:nvPr/>
+        </p:nvSpPr>
+        <p:spPr>
+          <a:xfrm>
+            <a:off x="7307884" y="31038761"/>
             <a:ext cx="4030675" cy="365760"/>
           </a:xfrm>
           <a:prstGeom prst="rect">
@@ -4305,13 +4371,13 @@
       </p:sp>
       <p:sp>
         <p:nvSpPr>
-          <p:cNvPr id="31" name="Rectangle 30"/>
+          <p:cNvPr id="33" name="Rectangle 32"/>
           <p:cNvSpPr/>
           <p:nvPr/>
         </p:nvSpPr>
         <p:spPr>
           <a:xfrm>
-            <a:off x="731520" y="26456293"/>
+            <a:off x="731520" y="31313081"/>
             <a:ext cx="10607040" cy="12801"/>
           </a:xfrm>
           <a:prstGeom prst="rect">
@@ -4349,13 +4415,13 @@
       </p:sp>
       <p:sp>
         <p:nvSpPr>
-          <p:cNvPr id="32" name="TextBox 31"/>
-          <p:cNvSpPr txBox="1"/>
-          <p:nvPr/>
-        </p:nvSpPr>
-        <p:spPr>
-          <a:xfrm>
-            <a:off x="731520" y="26538589"/>
+          <p:cNvPr id="34" name="TextBox 33"/>
+          <p:cNvSpPr txBox="1"/>
+          <p:nvPr/>
+        </p:nvSpPr>
+        <p:spPr>
+          <a:xfrm>
+            <a:off x="731520" y="31395377"/>
             <a:ext cx="6576364" cy="365760"/>
           </a:xfrm>
           <a:prstGeom prst="rect">
@@ -4391,13 +4457,13 @@
       </p:sp>
       <p:sp>
         <p:nvSpPr>
-          <p:cNvPr id="33" name="TextBox 32"/>
-          <p:cNvSpPr txBox="1"/>
-          <p:nvPr/>
-        </p:nvSpPr>
-        <p:spPr>
-          <a:xfrm>
-            <a:off x="7307884" y="26538589"/>
+          <p:cNvPr id="35" name="TextBox 34"/>
+          <p:cNvSpPr txBox="1"/>
+          <p:nvPr/>
+        </p:nvSpPr>
+        <p:spPr>
+          <a:xfrm>
+            <a:off x="7307884" y="31395377"/>
             <a:ext cx="4030675" cy="365760"/>
           </a:xfrm>
           <a:prstGeom prst="rect">
@@ -4433,13 +4499,13 @@
       </p:sp>
       <p:sp>
         <p:nvSpPr>
-          <p:cNvPr id="34" name="TextBox 33"/>
-          <p:cNvSpPr txBox="1"/>
-          <p:nvPr/>
-        </p:nvSpPr>
-        <p:spPr>
-          <a:xfrm>
-            <a:off x="731520" y="26849485"/>
+          <p:cNvPr id="36" name="TextBox 35"/>
+          <p:cNvSpPr txBox="1"/>
+          <p:nvPr/>
+        </p:nvSpPr>
+        <p:spPr>
+          <a:xfrm>
+            <a:off x="731520" y="31706273"/>
             <a:ext cx="6576364" cy="365760"/>
           </a:xfrm>
           <a:prstGeom prst="rect">
@@ -4475,13 +4541,13 @@
       </p:sp>
       <p:sp>
         <p:nvSpPr>
-          <p:cNvPr id="35" name="TextBox 34"/>
-          <p:cNvSpPr txBox="1"/>
-          <p:nvPr/>
-        </p:nvSpPr>
-        <p:spPr>
-          <a:xfrm>
-            <a:off x="7307884" y="26849485"/>
+          <p:cNvPr id="37" name="TextBox 36"/>
+          <p:cNvSpPr txBox="1"/>
+          <p:nvPr/>
+        </p:nvSpPr>
+        <p:spPr>
+          <a:xfrm>
+            <a:off x="7307884" y="31706273"/>
             <a:ext cx="4030675" cy="365760"/>
           </a:xfrm>
           <a:prstGeom prst="rect">
@@ -4517,13 +4583,13 @@
       </p:sp>
       <p:sp>
         <p:nvSpPr>
-          <p:cNvPr id="36" name="TextBox 35"/>
-          <p:cNvSpPr txBox="1"/>
-          <p:nvPr/>
-        </p:nvSpPr>
-        <p:spPr>
-          <a:xfrm>
-            <a:off x="731520" y="27160381"/>
+          <p:cNvPr id="38" name="TextBox 37"/>
+          <p:cNvSpPr txBox="1"/>
+          <p:nvPr/>
+        </p:nvSpPr>
+        <p:spPr>
+          <a:xfrm>
+            <a:off x="731520" y="32017169"/>
             <a:ext cx="6576364" cy="365760"/>
           </a:xfrm>
           <a:prstGeom prst="rect">
@@ -4559,13 +4625,13 @@
       </p:sp>
       <p:sp>
         <p:nvSpPr>
-          <p:cNvPr id="37" name="TextBox 36"/>
-          <p:cNvSpPr txBox="1"/>
-          <p:nvPr/>
-        </p:nvSpPr>
-        <p:spPr>
-          <a:xfrm>
-            <a:off x="7307884" y="27160381"/>
+          <p:cNvPr id="39" name="TextBox 38"/>
+          <p:cNvSpPr txBox="1"/>
+          <p:nvPr/>
+        </p:nvSpPr>
+        <p:spPr>
+          <a:xfrm>
+            <a:off x="7307884" y="32017169"/>
             <a:ext cx="4030675" cy="365760"/>
           </a:xfrm>
           <a:prstGeom prst="rect">
@@ -4601,13 +4667,13 @@
       </p:sp>
       <p:sp>
         <p:nvSpPr>
-          <p:cNvPr id="38" name="TextBox 37"/>
-          <p:cNvSpPr txBox="1"/>
-          <p:nvPr/>
-        </p:nvSpPr>
-        <p:spPr>
-          <a:xfrm>
-            <a:off x="731520" y="27471277"/>
+          <p:cNvPr id="40" name="TextBox 39"/>
+          <p:cNvSpPr txBox="1"/>
+          <p:nvPr/>
+        </p:nvSpPr>
+        <p:spPr>
+          <a:xfrm>
+            <a:off x="731520" y="32328065"/>
             <a:ext cx="6576364" cy="365760"/>
           </a:xfrm>
           <a:prstGeom prst="rect">
@@ -4643,13 +4709,13 @@
       </p:sp>
       <p:sp>
         <p:nvSpPr>
-          <p:cNvPr id="39" name="TextBox 38"/>
-          <p:cNvSpPr txBox="1"/>
-          <p:nvPr/>
-        </p:nvSpPr>
-        <p:spPr>
-          <a:xfrm>
-            <a:off x="7307884" y="27471277"/>
+          <p:cNvPr id="41" name="TextBox 40"/>
+          <p:cNvSpPr txBox="1"/>
+          <p:nvPr/>
+        </p:nvSpPr>
+        <p:spPr>
+          <a:xfrm>
+            <a:off x="7307884" y="32328065"/>
             <a:ext cx="4030675" cy="365760"/>
           </a:xfrm>
           <a:prstGeom prst="rect">
@@ -4685,13 +4751,13 @@
       </p:sp>
       <p:sp>
         <p:nvSpPr>
-          <p:cNvPr id="40" name="Rectangle 39"/>
+          <p:cNvPr id="42" name="Rectangle 41"/>
           <p:cNvSpPr/>
           <p:nvPr/>
         </p:nvSpPr>
         <p:spPr>
           <a:xfrm>
-            <a:off x="731520" y="27800461"/>
+            <a:off x="731520" y="32657249"/>
             <a:ext cx="10607040" cy="20116"/>
           </a:xfrm>
           <a:prstGeom prst="rect">
@@ -4729,7 +4795,7 @@
       </p:sp>
       <p:sp>
         <p:nvSpPr>
-          <p:cNvPr id="41" name="TextBox 40"/>
+          <p:cNvPr id="43" name="TextBox 42"/>
           <p:cNvSpPr txBox="1"/>
           <p:nvPr/>
         </p:nvSpPr>
@@ -4771,7 +4837,7 @@
       </p:sp>
       <p:sp>
         <p:nvSpPr>
-          <p:cNvPr id="42" name="Rectangle 41"/>
+          <p:cNvPr id="44" name="Rectangle 43"/>
           <p:cNvSpPr/>
           <p:nvPr/>
         </p:nvSpPr>
@@ -4815,7 +4881,7 @@
       </p:sp>
       <p:sp>
         <p:nvSpPr>
-          <p:cNvPr id="43" name="Rectangle 42"/>
+          <p:cNvPr id="45" name="Rectangle 44"/>
           <p:cNvSpPr/>
           <p:nvPr/>
         </p:nvSpPr>
@@ -4859,7 +4925,7 @@
       </p:sp>
       <p:sp>
         <p:nvSpPr>
-          <p:cNvPr id="44" name="TextBox 43"/>
+          <p:cNvPr id="46" name="TextBox 45"/>
           <p:cNvSpPr txBox="1"/>
           <p:nvPr/>
         </p:nvSpPr>
@@ -4901,7 +4967,7 @@
       </p:sp>
       <p:sp>
         <p:nvSpPr>
-          <p:cNvPr id="45" name="TextBox 44"/>
+          <p:cNvPr id="47" name="TextBox 46"/>
           <p:cNvSpPr txBox="1"/>
           <p:nvPr/>
         </p:nvSpPr>
@@ -4943,7 +5009,7 @@
       </p:sp>
       <p:sp>
         <p:nvSpPr>
-          <p:cNvPr id="46" name="TextBox 45"/>
+          <p:cNvPr id="48" name="TextBox 47"/>
           <p:cNvSpPr txBox="1"/>
           <p:nvPr/>
         </p:nvSpPr>
@@ -4985,7 +5051,7 @@
       </p:sp>
       <p:sp>
         <p:nvSpPr>
-          <p:cNvPr id="47" name="Rectangle 46"/>
+          <p:cNvPr id="49" name="Rectangle 48"/>
           <p:cNvSpPr/>
           <p:nvPr/>
         </p:nvSpPr>
@@ -5029,7 +5095,7 @@
       </p:sp>
       <p:sp>
         <p:nvSpPr>
-          <p:cNvPr id="48" name="TextBox 47"/>
+          <p:cNvPr id="50" name="TextBox 49"/>
           <p:cNvSpPr txBox="1"/>
           <p:nvPr/>
         </p:nvSpPr>
@@ -5071,7 +5137,7 @@
       </p:sp>
       <p:sp>
         <p:nvSpPr>
-          <p:cNvPr id="49" name="TextBox 48"/>
+          <p:cNvPr id="51" name="TextBox 50"/>
           <p:cNvSpPr txBox="1"/>
           <p:nvPr/>
         </p:nvSpPr>
@@ -5113,7 +5179,7 @@
       </p:sp>
       <p:sp>
         <p:nvSpPr>
-          <p:cNvPr id="50" name="TextBox 49"/>
+          <p:cNvPr id="52" name="TextBox 51"/>
           <p:cNvSpPr txBox="1"/>
           <p:nvPr/>
         </p:nvSpPr>
@@ -5155,7 +5221,7 @@
       </p:sp>
       <p:sp>
         <p:nvSpPr>
-          <p:cNvPr id="51" name="Rectangle 50"/>
+          <p:cNvPr id="53" name="Rectangle 52"/>
           <p:cNvSpPr/>
           <p:nvPr/>
         </p:nvSpPr>
@@ -5199,7 +5265,7 @@
       </p:sp>
       <p:sp>
         <p:nvSpPr>
-          <p:cNvPr id="52" name="TextBox 51"/>
+          <p:cNvPr id="54" name="TextBox 53"/>
           <p:cNvSpPr txBox="1"/>
           <p:nvPr/>
         </p:nvSpPr>
@@ -5241,7 +5307,7 @@
       </p:sp>
       <p:sp>
         <p:nvSpPr>
-          <p:cNvPr id="53" name="TextBox 52"/>
+          <p:cNvPr id="55" name="TextBox 54"/>
           <p:cNvSpPr txBox="1"/>
           <p:nvPr/>
         </p:nvSpPr>
@@ -5283,7 +5349,7 @@
       </p:sp>
       <p:sp>
         <p:nvSpPr>
-          <p:cNvPr id="54" name="TextBox 53"/>
+          <p:cNvPr id="56" name="TextBox 55"/>
           <p:cNvSpPr txBox="1"/>
           <p:nvPr/>
         </p:nvSpPr>
@@ -5325,7 +5391,7 @@
       </p:sp>
       <p:sp>
         <p:nvSpPr>
-          <p:cNvPr id="55" name="Rectangle 54"/>
+          <p:cNvPr id="57" name="Rectangle 56"/>
           <p:cNvSpPr/>
           <p:nvPr/>
         </p:nvSpPr>
@@ -5369,7 +5435,7 @@
       </p:sp>
       <p:sp>
         <p:nvSpPr>
-          <p:cNvPr id="56" name="TextBox 55"/>
+          <p:cNvPr id="58" name="TextBox 57"/>
           <p:cNvSpPr txBox="1"/>
           <p:nvPr/>
         </p:nvSpPr>
@@ -5411,7 +5477,7 @@
       </p:sp>
       <p:sp>
         <p:nvSpPr>
-          <p:cNvPr id="57" name="TextBox 56"/>
+          <p:cNvPr id="59" name="TextBox 58"/>
           <p:cNvSpPr txBox="1"/>
           <p:nvPr/>
         </p:nvSpPr>
@@ -5453,7 +5519,7 @@
       </p:sp>
       <p:sp>
         <p:nvSpPr>
-          <p:cNvPr id="58" name="TextBox 57"/>
+          <p:cNvPr id="60" name="TextBox 59"/>
           <p:cNvSpPr txBox="1"/>
           <p:nvPr/>
         </p:nvSpPr>
@@ -5495,7 +5561,7 @@
       </p:sp>
       <p:sp>
         <p:nvSpPr>
-          <p:cNvPr id="59" name="TextBox 58"/>
+          <p:cNvPr id="61" name="TextBox 60"/>
           <p:cNvSpPr txBox="1"/>
           <p:nvPr/>
         </p:nvSpPr>
@@ -5537,73 +5603,7 @@
       </p:sp>
       <p:pic>
         <p:nvPicPr>
-          <p:cNvPr id="60" name="Picture 59" descr="a_families.png"/>
-          <p:cNvPicPr>
-            <a:picLocks noChangeAspect="1"/>
-          </p:cNvPicPr>
-          <p:nvPr/>
-        </p:nvPicPr>
-        <p:blipFill>
-          <a:blip r:embed="rId5"/>
-          <a:stretch>
-            <a:fillRect/>
-          </a:stretch>
-        </p:blipFill>
-        <p:spPr>
-          <a:xfrm>
-            <a:off x="11704320" y="7763255"/>
-            <a:ext cx="9989819" cy="5361065"/>
-          </a:xfrm>
-          <a:prstGeom prst="rect">
-            <a:avLst/>
-          </a:prstGeom>
-        </p:spPr>
-      </p:pic>
-      <p:sp>
-        <p:nvSpPr>
-          <p:cNvPr id="61" name="TextBox 60"/>
-          <p:cNvSpPr txBox="1"/>
-          <p:nvPr/>
-        </p:nvSpPr>
-        <p:spPr>
-          <a:xfrm>
-            <a:off x="11704320" y="13215760"/>
-            <a:ext cx="9989819" cy="365760"/>
-          </a:xfrm>
-          <a:prstGeom prst="rect">
-            <a:avLst/>
-          </a:prstGeom>
-          <a:noFill/>
-        </p:spPr>
-        <p:txBody>
-          <a:bodyPr wrap="square" lIns="0" rIns="0" tIns="0" bIns="0">
-            <a:spAutoFit/>
-          </a:bodyPr>
-          <a:lstStyle/>
-          <a:p>
-            <a:pPr algn="l">
-              <a:lnSpc>
-                <a:spcPct val="120000"/>
-              </a:lnSpc>
-              <a:spcAft>
-                <a:spcPts val="0"/>
-              </a:spcAft>
-            </a:pPr>
-            <a:r>
-              <a:rPr sz="1200" b="0">
-                <a:solidFill>
-                  <a:srgbClr val="556575"/>
-                </a:solidFill>
-                <a:latin typeface="Arial"/>
-              </a:rPr>
-              <a:t>Figure 4.  Three detector families on the CottonWeedDet12 holdout, three seeds each. How the network is initialised is worth three times what the architecture is worth.</a:t>
-            </a:r>
-          </a:p>
-        </p:txBody>
-      </p:sp>
-      <p:pic>
-        <p:nvPicPr>
-          <p:cNvPr id="62" name="Picture 61" descr="b_zeroshot.png"/>
+          <p:cNvPr id="62" name="Picture 61" descr="a_families.png"/>
           <p:cNvPicPr>
             <a:picLocks noChangeAspect="1"/>
           </p:cNvPicPr>
@@ -5617,8 +5617,8 @@
         </p:blipFill>
         <p:spPr>
           <a:xfrm>
-            <a:off x="22197060" y="7763255"/>
-            <a:ext cx="9989819" cy="4817913"/>
+            <a:off x="11704320" y="7763255"/>
+            <a:ext cx="9989819" cy="5361065"/>
           </a:xfrm>
           <a:prstGeom prst="rect">
             <a:avLst/>
@@ -5633,7 +5633,7 @@
         </p:nvSpPr>
         <p:spPr>
           <a:xfrm>
-            <a:off x="22197060" y="12672608"/>
+            <a:off x="11704320" y="13215760"/>
             <a:ext cx="9989819" cy="365760"/>
           </a:xfrm>
           <a:prstGeom prst="rect">
@@ -5662,56 +5662,14 @@
                 </a:solidFill>
                 <a:latin typeface="Arial"/>
               </a:rPr>
-              <a:t>Figure 5.  One deterministic pass per model, no repeats. Fifteen zero-shot vision-language models against the fine-tuned detector: the best of them reaches 0.434 against 0.929, and five produce no usable grounding at all.</a:t>
-            </a:r>
-          </a:p>
-        </p:txBody>
-      </p:sp>
-      <p:sp>
-        <p:nvSpPr>
-          <p:cNvPr id="64" name="TextBox 63"/>
-          <p:cNvSpPr txBox="1"/>
-          <p:nvPr/>
-        </p:nvSpPr>
-        <p:spPr>
-          <a:xfrm>
-            <a:off x="11704320" y="13947281"/>
-            <a:ext cx="20482560" cy="365760"/>
-          </a:xfrm>
-          <a:prstGeom prst="rect">
-            <a:avLst/>
-          </a:prstGeom>
-          <a:noFill/>
-        </p:spPr>
-        <p:txBody>
-          <a:bodyPr wrap="square" lIns="0" rIns="0" tIns="0" bIns="0">
-            <a:spAutoFit/>
-          </a:bodyPr>
-          <a:lstStyle/>
-          <a:p>
-            <a:pPr algn="l">
-              <a:lnSpc>
-                <a:spcPct val="100000"/>
-              </a:lnSpc>
-              <a:spcAft>
-                <a:spcPts val="0"/>
-              </a:spcAft>
-            </a:pPr>
-            <a:r>
-              <a:rPr sz="1800" b="1">
-                <a:solidFill>
-                  <a:srgbClr val="1E293B"/>
-                </a:solidFill>
-                <a:latin typeface="Arial"/>
-              </a:rPr>
-              <a:t>Does more harvested data help?</a:t>
+              <a:t>Figure 5.  Three detector families on the CottonWeedDet12 holdout, three seeds each. How the network is initialised is worth three times what the architecture is worth.</a:t>
             </a:r>
           </a:p>
         </p:txBody>
       </p:sp>
       <p:pic>
         <p:nvPicPr>
-          <p:cNvPr id="65" name="Picture 64" descr="c_ladder.png"/>
+          <p:cNvPr id="64" name="Picture 63" descr="b_zeroshot.png"/>
           <p:cNvPicPr>
             <a:picLocks noChangeAspect="1"/>
           </p:cNvPicPr>
@@ -5725,6 +5683,114 @@
         </p:blipFill>
         <p:spPr>
           <a:xfrm>
+            <a:off x="22197060" y="7763255"/>
+            <a:ext cx="9989819" cy="4817913"/>
+          </a:xfrm>
+          <a:prstGeom prst="rect">
+            <a:avLst/>
+          </a:prstGeom>
+        </p:spPr>
+      </p:pic>
+      <p:sp>
+        <p:nvSpPr>
+          <p:cNvPr id="65" name="TextBox 64"/>
+          <p:cNvSpPr txBox="1"/>
+          <p:nvPr/>
+        </p:nvSpPr>
+        <p:spPr>
+          <a:xfrm>
+            <a:off x="22197060" y="12672608"/>
+            <a:ext cx="9989819" cy="365760"/>
+          </a:xfrm>
+          <a:prstGeom prst="rect">
+            <a:avLst/>
+          </a:prstGeom>
+          <a:noFill/>
+        </p:spPr>
+        <p:txBody>
+          <a:bodyPr wrap="square" lIns="0" rIns="0" tIns="0" bIns="0">
+            <a:spAutoFit/>
+          </a:bodyPr>
+          <a:lstStyle/>
+          <a:p>
+            <a:pPr algn="l">
+              <a:lnSpc>
+                <a:spcPct val="120000"/>
+              </a:lnSpc>
+              <a:spcAft>
+                <a:spcPts val="0"/>
+              </a:spcAft>
+            </a:pPr>
+            <a:r>
+              <a:rPr sz="1200" b="0">
+                <a:solidFill>
+                  <a:srgbClr val="556575"/>
+                </a:solidFill>
+                <a:latin typeface="Arial"/>
+              </a:rPr>
+              <a:t>Figure 6.  One deterministic pass per model, no repeats. Fifteen zero-shot vision-language models against the fine-tuned detector: the best of them reaches 0.434 against 0.929, and five produce no usable grounding at all.</a:t>
+            </a:r>
+          </a:p>
+        </p:txBody>
+      </p:sp>
+      <p:sp>
+        <p:nvSpPr>
+          <p:cNvPr id="66" name="TextBox 65"/>
+          <p:cNvSpPr txBox="1"/>
+          <p:nvPr/>
+        </p:nvSpPr>
+        <p:spPr>
+          <a:xfrm>
+            <a:off x="11704320" y="13947281"/>
+            <a:ext cx="20482560" cy="365760"/>
+          </a:xfrm>
+          <a:prstGeom prst="rect">
+            <a:avLst/>
+          </a:prstGeom>
+          <a:noFill/>
+        </p:spPr>
+        <p:txBody>
+          <a:bodyPr wrap="square" lIns="0" rIns="0" tIns="0" bIns="0">
+            <a:spAutoFit/>
+          </a:bodyPr>
+          <a:lstStyle/>
+          <a:p>
+            <a:pPr algn="l">
+              <a:lnSpc>
+                <a:spcPct val="100000"/>
+              </a:lnSpc>
+              <a:spcAft>
+                <a:spcPts val="0"/>
+              </a:spcAft>
+            </a:pPr>
+            <a:r>
+              <a:rPr sz="1800" b="1">
+                <a:solidFill>
+                  <a:srgbClr val="1E293B"/>
+                </a:solidFill>
+                <a:latin typeface="Arial"/>
+              </a:rPr>
+              <a:t>Does more harvested data help?</a:t>
+            </a:r>
+          </a:p>
+        </p:txBody>
+      </p:sp>
+      <p:pic>
+        <p:nvPicPr>
+          <p:cNvPr id="67" name="Picture 66" descr="c_ladder.png"/>
+          <p:cNvPicPr>
+            <a:picLocks noChangeAspect="1"/>
+          </p:cNvPicPr>
+          <p:nvPr/>
+        </p:nvPicPr>
+        <p:blipFill>
+          <a:blip r:embed="rId8"/>
+          <a:stretch>
+            <a:fillRect/>
+          </a:stretch>
+        </p:blipFill>
+        <p:spPr>
+          <a:xfrm>
             <a:off x="11704320" y="14258176"/>
             <a:ext cx="9989819" cy="2543654"/>
           </a:xfrm>
@@ -5735,7 +5801,7 @@
       </p:pic>
       <p:sp>
         <p:nvSpPr>
-          <p:cNvPr id="66" name="TextBox 65"/>
+          <p:cNvPr id="68" name="TextBox 67"/>
           <p:cNvSpPr txBox="1"/>
           <p:nvPr/>
         </p:nvSpPr>
@@ -5770,14 +5836,14 @@
                 </a:solidFill>
                 <a:latin typeface="Arial"/>
               </a:rPr>
-              <a:t>Figure 6.  (c) Twelve times the training data costs 0.0189, three seeds at every rung. (d) The same eight checkpoints on a second dataset, class-agnostic, nothing of which it saw in training and 0 images excluded by the leak check; the series labels in (c) apply to (d). Both exams fall, so the narrow metric is not what makes the ladder drop.</a:t>
-            </a:r>
-          </a:p>
-        </p:txBody>
-      </p:sp>
-      <p:sp>
-        <p:nvSpPr>
-          <p:cNvPr id="67" name="TextBox 66"/>
+              <a:t>Figure 7.  (c) Twelve times the training data costs 0.0189, three seeds at every rung. (d) The same eight checkpoints on a second dataset, class-agnostic, nothing of which it saw in training and 0 images excluded by the leak check; the series labels in (c) apply to (d). Both exams fall, so the narrow metric is not what makes the ladder drop.</a:t>
+            </a:r>
+          </a:p>
+        </p:txBody>
+      </p:sp>
+      <p:sp>
+        <p:nvSpPr>
+          <p:cNvPr id="69" name="TextBox 68"/>
           <p:cNvSpPr txBox="1"/>
           <p:nvPr/>
         </p:nvSpPr>
@@ -5819,7 +5885,7 @@
       </p:sp>
       <p:sp>
         <p:nvSpPr>
-          <p:cNvPr id="68" name="Rectangle 67"/>
+          <p:cNvPr id="70" name="Rectangle 69"/>
           <p:cNvSpPr/>
           <p:nvPr/>
         </p:nvSpPr>
@@ -5863,7 +5929,7 @@
       </p:sp>
       <p:sp>
         <p:nvSpPr>
-          <p:cNvPr id="69" name="TextBox 68"/>
+          <p:cNvPr id="71" name="TextBox 70"/>
           <p:cNvSpPr txBox="1"/>
           <p:nvPr/>
         </p:nvSpPr>
@@ -5905,7 +5971,7 @@
       </p:sp>
       <p:sp>
         <p:nvSpPr>
-          <p:cNvPr id="70" name="TextBox 69"/>
+          <p:cNvPr id="72" name="TextBox 71"/>
           <p:cNvSpPr txBox="1"/>
           <p:nvPr/>
         </p:nvSpPr>
@@ -5947,7 +6013,7 @@
       </p:sp>
       <p:sp>
         <p:nvSpPr>
-          <p:cNvPr id="71" name="TextBox 70"/>
+          <p:cNvPr id="73" name="TextBox 72"/>
           <p:cNvSpPr txBox="1"/>
           <p:nvPr/>
         </p:nvSpPr>
@@ -5989,7 +6055,7 @@
       </p:sp>
       <p:sp>
         <p:nvSpPr>
-          <p:cNvPr id="72" name="Rectangle 71"/>
+          <p:cNvPr id="74" name="Rectangle 73"/>
           <p:cNvSpPr/>
           <p:nvPr/>
         </p:nvSpPr>
@@ -6033,7 +6099,7 @@
       </p:sp>
       <p:sp>
         <p:nvSpPr>
-          <p:cNvPr id="73" name="TextBox 72"/>
+          <p:cNvPr id="75" name="TextBox 74"/>
           <p:cNvSpPr txBox="1"/>
           <p:nvPr/>
         </p:nvSpPr>
@@ -6075,7 +6141,7 @@
       </p:sp>
       <p:sp>
         <p:nvSpPr>
-          <p:cNvPr id="74" name="TextBox 73"/>
+          <p:cNvPr id="76" name="TextBox 75"/>
           <p:cNvSpPr txBox="1"/>
           <p:nvPr/>
         </p:nvSpPr>
@@ -6117,7 +6183,7 @@
       </p:sp>
       <p:sp>
         <p:nvSpPr>
-          <p:cNvPr id="75" name="TextBox 74"/>
+          <p:cNvPr id="77" name="TextBox 76"/>
           <p:cNvSpPr txBox="1"/>
           <p:nvPr/>
         </p:nvSpPr>
@@ -6159,7 +6225,7 @@
       </p:sp>
       <p:sp>
         <p:nvSpPr>
-          <p:cNvPr id="76" name="TextBox 75"/>
+          <p:cNvPr id="78" name="TextBox 77"/>
           <p:cNvSpPr txBox="1"/>
           <p:nvPr/>
         </p:nvSpPr>
@@ -6201,7 +6267,7 @@
       </p:sp>
       <p:sp>
         <p:nvSpPr>
-          <p:cNvPr id="77" name="TextBox 76"/>
+          <p:cNvPr id="79" name="TextBox 78"/>
           <p:cNvSpPr txBox="1"/>
           <p:nvPr/>
         </p:nvSpPr>
@@ -6243,7 +6309,7 @@
       </p:sp>
       <p:sp>
         <p:nvSpPr>
-          <p:cNvPr id="78" name="TextBox 77"/>
+          <p:cNvPr id="80" name="TextBox 79"/>
           <p:cNvSpPr txBox="1"/>
           <p:nvPr/>
         </p:nvSpPr>
@@ -6285,7 +6351,7 @@
       </p:sp>
       <p:sp>
         <p:nvSpPr>
-          <p:cNvPr id="79" name="TextBox 78"/>
+          <p:cNvPr id="81" name="TextBox 80"/>
           <p:cNvSpPr txBox="1"/>
           <p:nvPr/>
         </p:nvSpPr>
@@ -6327,7 +6393,7 @@
       </p:sp>
       <p:sp>
         <p:nvSpPr>
-          <p:cNvPr id="80" name="TextBox 79"/>
+          <p:cNvPr id="82" name="TextBox 81"/>
           <p:cNvSpPr txBox="1"/>
           <p:nvPr/>
         </p:nvSpPr>
@@ -6369,7 +6435,7 @@
       </p:sp>
       <p:sp>
         <p:nvSpPr>
-          <p:cNvPr id="81" name="TextBox 80"/>
+          <p:cNvPr id="83" name="TextBox 82"/>
           <p:cNvSpPr txBox="1"/>
           <p:nvPr/>
         </p:nvSpPr>
@@ -6411,7 +6477,7 @@
       </p:sp>
       <p:sp>
         <p:nvSpPr>
-          <p:cNvPr id="82" name="TextBox 81"/>
+          <p:cNvPr id="84" name="TextBox 83"/>
           <p:cNvSpPr txBox="1"/>
           <p:nvPr/>
         </p:nvSpPr>
@@ -6453,7 +6519,7 @@
       </p:sp>
       <p:sp>
         <p:nvSpPr>
-          <p:cNvPr id="83" name="TextBox 82"/>
+          <p:cNvPr id="85" name="TextBox 84"/>
           <p:cNvSpPr txBox="1"/>
           <p:nvPr/>
         </p:nvSpPr>
@@ -6495,7 +6561,7 @@
       </p:sp>
       <p:sp>
         <p:nvSpPr>
-          <p:cNvPr id="84" name="TextBox 83"/>
+          <p:cNvPr id="86" name="TextBox 85"/>
           <p:cNvSpPr txBox="1"/>
           <p:nvPr/>
         </p:nvSpPr>
@@ -6537,7 +6603,7 @@
       </p:sp>
       <p:sp>
         <p:nvSpPr>
-          <p:cNvPr id="85" name="Rectangle 84"/>
+          <p:cNvPr id="87" name="Rectangle 86"/>
           <p:cNvSpPr/>
           <p:nvPr/>
         </p:nvSpPr>
@@ -6581,7 +6647,7 @@
       </p:sp>
       <p:sp>
         <p:nvSpPr>
-          <p:cNvPr id="86" name="TextBox 85"/>
+          <p:cNvPr id="88" name="TextBox 87"/>
           <p:cNvSpPr txBox="1"/>
           <p:nvPr/>
         </p:nvSpPr>
@@ -6623,7 +6689,7 @@
       </p:sp>
       <p:sp>
         <p:nvSpPr>
-          <p:cNvPr id="87" name="TextBox 86"/>
+          <p:cNvPr id="89" name="TextBox 88"/>
           <p:cNvSpPr txBox="1"/>
           <p:nvPr/>
         </p:nvSpPr>
@@ -6665,14 +6731,14 @@
       </p:sp>
       <p:pic>
         <p:nvPicPr>
-          <p:cNvPr id="88" name="Picture 87" descr="e_supervision.png"/>
+          <p:cNvPr id="90" name="Picture 89" descr="e_supervision.png"/>
           <p:cNvPicPr>
             <a:picLocks noChangeAspect="1"/>
           </p:cNvPicPr>
           <p:nvPr/>
         </p:nvPicPr>
         <p:blipFill>
-          <a:blip r:embed="rId8"/>
+          <a:blip r:embed="rId9"/>
           <a:stretch>
             <a:fillRect/>
           </a:stretch>
@@ -6689,7 +6755,7 @@
       </p:pic>
       <p:sp>
         <p:nvSpPr>
-          <p:cNvPr id="89" name="TextBox 88"/>
+          <p:cNvPr id="91" name="TextBox 90"/>
           <p:cNvSpPr txBox="1"/>
           <p:nvPr/>
         </p:nvSpPr>
@@ -6724,14 +6790,14 @@
                 </a:solidFill>
                 <a:latin typeface="Arial"/>
               </a:rPr>
-              <a:t>Figure 7.  Every arm on one frozen corpus of real incidents from this project's own history -- 116 incidents and 33 controls -- scored by the project's own scorer: a detection counts only when the arm returns an issue verdict carrying a finding at or above a severity bar, and a case that produced no answer leaves the denominator rather than counting as a miss. Up and to the left is better. Open circle: the model reads raw artifact excerpts. Filled: the same model with a retrieval round over the same artifacts. The retrieval tier is worth +0.149 recall to the 27B and +0.012 to the 14B, so tiering pays where the model can use it and not otherwise.</a:t>
-            </a:r>
-          </a:p>
-        </p:txBody>
-      </p:sp>
-      <p:sp>
-        <p:nvSpPr>
-          <p:cNvPr id="90" name="TextBox 89"/>
+              <a:t>Figure 8.  Every arm on one frozen corpus of real incidents from this project's own history -- 116 incidents and 33 controls -- scored by the project's own scorer: a detection counts only when the arm returns an issue verdict carrying a finding at or above a severity bar, and a case that produced no answer leaves the denominator rather than counting as a miss. Up and to the left is better. Open circle: the model reads raw artifact excerpts. Filled: the same model with a retrieval round over the same artifacts. The retrieval tier is worth +0.149 recall to the 27B and +0.012 to the 14B, so tiering pays where the model can use it and not otherwise.</a:t>
+            </a:r>
+          </a:p>
+        </p:txBody>
+      </p:sp>
+      <p:sp>
+        <p:nvSpPr>
+          <p:cNvPr id="92" name="TextBox 91"/>
           <p:cNvSpPr txBox="1"/>
           <p:nvPr/>
         </p:nvSpPr>
@@ -6773,7 +6839,7 @@
       </p:sp>
       <p:sp>
         <p:nvSpPr>
-          <p:cNvPr id="91" name="Rectangle 90"/>
+          <p:cNvPr id="93" name="Rectangle 92"/>
           <p:cNvSpPr/>
           <p:nvPr/>
         </p:nvSpPr>
@@ -6817,7 +6883,7 @@
       </p:sp>
       <p:sp>
         <p:nvSpPr>
-          <p:cNvPr id="92" name="TextBox 91"/>
+          <p:cNvPr id="94" name="TextBox 93"/>
           <p:cNvSpPr txBox="1"/>
           <p:nvPr/>
         </p:nvSpPr>
@@ -6859,7 +6925,7 @@
       </p:sp>
       <p:sp>
         <p:nvSpPr>
-          <p:cNvPr id="93" name="TextBox 92"/>
+          <p:cNvPr id="95" name="TextBox 94"/>
           <p:cNvSpPr txBox="1"/>
           <p:nvPr/>
         </p:nvSpPr>
@@ -6901,7 +6967,7 @@
       </p:sp>
       <p:sp>
         <p:nvSpPr>
-          <p:cNvPr id="94" name="TextBox 93"/>
+          <p:cNvPr id="96" name="TextBox 95"/>
           <p:cNvSpPr txBox="1"/>
           <p:nvPr/>
         </p:nvSpPr>
@@ -6943,7 +7009,7 @@
       </p:sp>
       <p:sp>
         <p:nvSpPr>
-          <p:cNvPr id="95" name="TextBox 94"/>
+          <p:cNvPr id="97" name="TextBox 96"/>
           <p:cNvSpPr txBox="1"/>
           <p:nvPr/>
         </p:nvSpPr>
@@ -6985,7 +7051,7 @@
       </p:sp>
       <p:sp>
         <p:nvSpPr>
-          <p:cNvPr id="96" name="TextBox 95"/>
+          <p:cNvPr id="98" name="TextBox 97"/>
           <p:cNvSpPr txBox="1"/>
           <p:nvPr/>
         </p:nvSpPr>
@@ -7027,7 +7093,7 @@
       </p:sp>
       <p:sp>
         <p:nvSpPr>
-          <p:cNvPr id="97" name="TextBox 96"/>
+          <p:cNvPr id="99" name="TextBox 98"/>
           <p:cNvSpPr txBox="1"/>
           <p:nvPr/>
         </p:nvSpPr>
@@ -7069,7 +7135,7 @@
       </p:sp>
       <p:sp>
         <p:nvSpPr>
-          <p:cNvPr id="98" name="Rectangle 97"/>
+          <p:cNvPr id="100" name="Rectangle 99"/>
           <p:cNvSpPr/>
           <p:nvPr/>
         </p:nvSpPr>
@@ -7113,7 +7179,7 @@
       </p:sp>
       <p:sp>
         <p:nvSpPr>
-          <p:cNvPr id="99" name="TextBox 98"/>
+          <p:cNvPr id="101" name="TextBox 100"/>
           <p:cNvSpPr txBox="1"/>
           <p:nvPr/>
         </p:nvSpPr>
@@ -7155,7 +7221,7 @@
       </p:sp>
       <p:sp>
         <p:nvSpPr>
-          <p:cNvPr id="100" name="TextBox 99"/>
+          <p:cNvPr id="102" name="TextBox 101"/>
           <p:cNvSpPr txBox="1"/>
           <p:nvPr/>
         </p:nvSpPr>
@@ -7197,7 +7263,7 @@
       </p:sp>
       <p:sp>
         <p:nvSpPr>
-          <p:cNvPr id="101" name="TextBox 100"/>
+          <p:cNvPr id="103" name="TextBox 102"/>
           <p:cNvSpPr txBox="1"/>
           <p:nvPr/>
         </p:nvSpPr>
@@ -7239,7 +7305,7 @@
       </p:sp>
       <p:sp>
         <p:nvSpPr>
-          <p:cNvPr id="102" name="TextBox 101"/>
+          <p:cNvPr id="104" name="TextBox 103"/>
           <p:cNvSpPr txBox="1"/>
           <p:nvPr/>
         </p:nvSpPr>
@@ -7281,7 +7347,7 @@
       </p:sp>
       <p:sp>
         <p:nvSpPr>
-          <p:cNvPr id="103" name="TextBox 102"/>
+          <p:cNvPr id="105" name="TextBox 104"/>
           <p:cNvSpPr txBox="1"/>
           <p:nvPr/>
         </p:nvSpPr>
@@ -7323,7 +7389,7 @@
       </p:sp>
       <p:sp>
         <p:nvSpPr>
-          <p:cNvPr id="104" name="TextBox 103"/>
+          <p:cNvPr id="106" name="TextBox 105"/>
           <p:cNvSpPr txBox="1"/>
           <p:nvPr/>
         </p:nvSpPr>
@@ -7365,7 +7431,7 @@
       </p:sp>
       <p:sp>
         <p:nvSpPr>
-          <p:cNvPr id="105" name="TextBox 104"/>
+          <p:cNvPr id="107" name="TextBox 106"/>
           <p:cNvSpPr txBox="1"/>
           <p:nvPr/>
         </p:nvSpPr>
@@ -7407,7 +7473,7 @@
       </p:sp>
       <p:sp>
         <p:nvSpPr>
-          <p:cNvPr id="106" name="TextBox 105"/>
+          <p:cNvPr id="108" name="TextBox 107"/>
           <p:cNvSpPr txBox="1"/>
           <p:nvPr/>
         </p:nvSpPr>
@@ -7449,7 +7515,7 @@
       </p:sp>
       <p:sp>
         <p:nvSpPr>
-          <p:cNvPr id="107" name="TextBox 106"/>
+          <p:cNvPr id="109" name="TextBox 108"/>
           <p:cNvSpPr txBox="1"/>
           <p:nvPr/>
         </p:nvSpPr>
@@ -7491,7 +7557,7 @@
       </p:sp>
       <p:sp>
         <p:nvSpPr>
-          <p:cNvPr id="108" name="TextBox 107"/>
+          <p:cNvPr id="110" name="TextBox 109"/>
           <p:cNvSpPr txBox="1"/>
           <p:nvPr/>
         </p:nvSpPr>
@@ -7533,7 +7599,7 @@
       </p:sp>
       <p:sp>
         <p:nvSpPr>
-          <p:cNvPr id="109" name="TextBox 108"/>
+          <p:cNvPr id="111" name="TextBox 110"/>
           <p:cNvSpPr txBox="1"/>
           <p:nvPr/>
         </p:nvSpPr>
@@ -7575,7 +7641,7 @@
       </p:sp>
       <p:sp>
         <p:nvSpPr>
-          <p:cNvPr id="110" name="TextBox 109"/>
+          <p:cNvPr id="112" name="TextBox 111"/>
           <p:cNvSpPr txBox="1"/>
           <p:nvPr/>
         </p:nvSpPr>
@@ -7617,7 +7683,7 @@
       </p:sp>
       <p:sp>
         <p:nvSpPr>
-          <p:cNvPr id="111" name="TextBox 110"/>
+          <p:cNvPr id="113" name="TextBox 112"/>
           <p:cNvSpPr txBox="1"/>
           <p:nvPr/>
         </p:nvSpPr>
@@ -7659,7 +7725,7 @@
       </p:sp>
       <p:sp>
         <p:nvSpPr>
-          <p:cNvPr id="112" name="TextBox 111"/>
+          <p:cNvPr id="114" name="TextBox 113"/>
           <p:cNvSpPr txBox="1"/>
           <p:nvPr/>
         </p:nvSpPr>
@@ -7701,7 +7767,7 @@
       </p:sp>
       <p:sp>
         <p:nvSpPr>
-          <p:cNvPr id="113" name="TextBox 112"/>
+          <p:cNvPr id="115" name="TextBox 114"/>
           <p:cNvSpPr txBox="1"/>
           <p:nvPr/>
         </p:nvSpPr>
@@ -7743,7 +7809,7 @@
       </p:sp>
       <p:sp>
         <p:nvSpPr>
-          <p:cNvPr id="114" name="TextBox 113"/>
+          <p:cNvPr id="116" name="TextBox 115"/>
           <p:cNvSpPr txBox="1"/>
           <p:nvPr/>
         </p:nvSpPr>
@@ -7785,7 +7851,7 @@
       </p:sp>
       <p:sp>
         <p:nvSpPr>
-          <p:cNvPr id="115" name="TextBox 114"/>
+          <p:cNvPr id="117" name="TextBox 116"/>
           <p:cNvSpPr txBox="1"/>
           <p:nvPr/>
         </p:nvSpPr>
@@ -7827,7 +7893,7 @@
       </p:sp>
       <p:sp>
         <p:nvSpPr>
-          <p:cNvPr id="116" name="TextBox 115"/>
+          <p:cNvPr id="118" name="TextBox 117"/>
           <p:cNvSpPr txBox="1"/>
           <p:nvPr/>
         </p:nvSpPr>
@@ -7869,7 +7935,7 @@
       </p:sp>
       <p:sp>
         <p:nvSpPr>
-          <p:cNvPr id="117" name="TextBox 116"/>
+          <p:cNvPr id="119" name="TextBox 118"/>
           <p:cNvSpPr txBox="1"/>
           <p:nvPr/>
         </p:nvSpPr>
@@ -7911,7 +7977,7 @@
       </p:sp>
       <p:sp>
         <p:nvSpPr>
-          <p:cNvPr id="118" name="TextBox 117"/>
+          <p:cNvPr id="120" name="TextBox 119"/>
           <p:cNvSpPr txBox="1"/>
           <p:nvPr/>
         </p:nvSpPr>
@@ -7953,7 +8019,7 @@
       </p:sp>
       <p:sp>
         <p:nvSpPr>
-          <p:cNvPr id="119" name="TextBox 118"/>
+          <p:cNvPr id="121" name="TextBox 120"/>
           <p:cNvSpPr txBox="1"/>
           <p:nvPr/>
         </p:nvSpPr>
@@ -7995,7 +8061,7 @@
       </p:sp>
       <p:sp>
         <p:nvSpPr>
-          <p:cNvPr id="120" name="TextBox 119"/>
+          <p:cNvPr id="122" name="TextBox 121"/>
           <p:cNvSpPr txBox="1"/>
           <p:nvPr/>
         </p:nvSpPr>
@@ -8037,7 +8103,7 @@
       </p:sp>
       <p:sp>
         <p:nvSpPr>
-          <p:cNvPr id="121" name="TextBox 120"/>
+          <p:cNvPr id="123" name="TextBox 122"/>
           <p:cNvSpPr txBox="1"/>
           <p:nvPr/>
         </p:nvSpPr>
@@ -8079,7 +8145,7 @@
       </p:sp>
       <p:sp>
         <p:nvSpPr>
-          <p:cNvPr id="122" name="TextBox 121"/>
+          <p:cNvPr id="124" name="TextBox 123"/>
           <p:cNvSpPr txBox="1"/>
           <p:nvPr/>
         </p:nvSpPr>
@@ -8121,7 +8187,7 @@
       </p:sp>
       <p:sp>
         <p:nvSpPr>
-          <p:cNvPr id="123" name="TextBox 122"/>
+          <p:cNvPr id="125" name="TextBox 124"/>
           <p:cNvSpPr txBox="1"/>
           <p:nvPr/>
         </p:nvSpPr>
@@ -8163,7 +8229,7 @@
       </p:sp>
       <p:sp>
         <p:nvSpPr>
-          <p:cNvPr id="124" name="TextBox 123"/>
+          <p:cNvPr id="126" name="TextBox 125"/>
           <p:cNvSpPr txBox="1"/>
           <p:nvPr/>
         </p:nvSpPr>
@@ -8205,7 +8271,7 @@
       </p:sp>
       <p:sp>
         <p:nvSpPr>
-          <p:cNvPr id="125" name="TextBox 124"/>
+          <p:cNvPr id="127" name="TextBox 126"/>
           <p:cNvSpPr txBox="1"/>
           <p:nvPr/>
         </p:nvSpPr>
@@ -8247,7 +8313,7 @@
       </p:sp>
       <p:sp>
         <p:nvSpPr>
-          <p:cNvPr id="126" name="TextBox 125"/>
+          <p:cNvPr id="128" name="TextBox 127"/>
           <p:cNvSpPr txBox="1"/>
           <p:nvPr/>
         </p:nvSpPr>
@@ -8289,7 +8355,7 @@
       </p:sp>
       <p:sp>
         <p:nvSpPr>
-          <p:cNvPr id="127" name="TextBox 126"/>
+          <p:cNvPr id="129" name="TextBox 128"/>
           <p:cNvSpPr txBox="1"/>
           <p:nvPr/>
         </p:nvSpPr>
@@ -8331,7 +8397,7 @@
       </p:sp>
       <p:sp>
         <p:nvSpPr>
-          <p:cNvPr id="128" name="TextBox 127"/>
+          <p:cNvPr id="130" name="TextBox 129"/>
           <p:cNvSpPr txBox="1"/>
           <p:nvPr/>
         </p:nvSpPr>
@@ -8373,7 +8439,7 @@
       </p:sp>
       <p:sp>
         <p:nvSpPr>
-          <p:cNvPr id="129" name="TextBox 128"/>
+          <p:cNvPr id="131" name="TextBox 130"/>
           <p:cNvSpPr txBox="1"/>
           <p:nvPr/>
         </p:nvSpPr>
@@ -8415,7 +8481,7 @@
       </p:sp>
       <p:sp>
         <p:nvSpPr>
-          <p:cNvPr id="130" name="TextBox 129"/>
+          <p:cNvPr id="132" name="TextBox 131"/>
           <p:cNvSpPr txBox="1"/>
           <p:nvPr/>
         </p:nvSpPr>
@@ -8457,7 +8523,7 @@
       </p:sp>
       <p:sp>
         <p:nvSpPr>
-          <p:cNvPr id="131" name="TextBox 130"/>
+          <p:cNvPr id="133" name="TextBox 132"/>
           <p:cNvSpPr txBox="1"/>
           <p:nvPr/>
         </p:nvSpPr>
@@ -8499,7 +8565,7 @@
       </p:sp>
       <p:sp>
         <p:nvSpPr>
-          <p:cNvPr id="132" name="TextBox 131"/>
+          <p:cNvPr id="134" name="TextBox 133"/>
           <p:cNvSpPr txBox="1"/>
           <p:nvPr/>
         </p:nvSpPr>
@@ -8541,7 +8607,7 @@
       </p:sp>
       <p:sp>
         <p:nvSpPr>
-          <p:cNvPr id="133" name="TextBox 132"/>
+          <p:cNvPr id="135" name="TextBox 134"/>
           <p:cNvSpPr txBox="1"/>
           <p:nvPr/>
         </p:nvSpPr>
@@ -8583,7 +8649,7 @@
       </p:sp>
       <p:sp>
         <p:nvSpPr>
-          <p:cNvPr id="134" name="TextBox 133"/>
+          <p:cNvPr id="136" name="TextBox 135"/>
           <p:cNvSpPr txBox="1"/>
           <p:nvPr/>
         </p:nvSpPr>
@@ -8625,7 +8691,7 @@
       </p:sp>
       <p:sp>
         <p:nvSpPr>
-          <p:cNvPr id="135" name="TextBox 134"/>
+          <p:cNvPr id="137" name="TextBox 136"/>
           <p:cNvSpPr txBox="1"/>
           <p:nvPr/>
         </p:nvSpPr>
@@ -8667,7 +8733,7 @@
       </p:sp>
       <p:sp>
         <p:nvSpPr>
-          <p:cNvPr id="136" name="TextBox 135"/>
+          <p:cNvPr id="138" name="TextBox 137"/>
           <p:cNvSpPr txBox="1"/>
           <p:nvPr/>
         </p:nvSpPr>
@@ -8709,7 +8775,7 @@
       </p:sp>
       <p:sp>
         <p:nvSpPr>
-          <p:cNvPr id="137" name="TextBox 136"/>
+          <p:cNvPr id="139" name="TextBox 138"/>
           <p:cNvSpPr txBox="1"/>
           <p:nvPr/>
         </p:nvSpPr>
@@ -8751,7 +8817,7 @@
       </p:sp>
       <p:sp>
         <p:nvSpPr>
-          <p:cNvPr id="138" name="TextBox 137"/>
+          <p:cNvPr id="140" name="TextBox 139"/>
           <p:cNvSpPr txBox="1"/>
           <p:nvPr/>
         </p:nvSpPr>
@@ -8793,7 +8859,7 @@
       </p:sp>
       <p:sp>
         <p:nvSpPr>
-          <p:cNvPr id="139" name="TextBox 138"/>
+          <p:cNvPr id="141" name="TextBox 140"/>
           <p:cNvSpPr txBox="1"/>
           <p:nvPr/>
         </p:nvSpPr>
@@ -8835,7 +8901,7 @@
       </p:sp>
       <p:sp>
         <p:nvSpPr>
-          <p:cNvPr id="140" name="TextBox 139"/>
+          <p:cNvPr id="142" name="TextBox 141"/>
           <p:cNvSpPr txBox="1"/>
           <p:nvPr/>
         </p:nvSpPr>
@@ -8877,7 +8943,7 @@
       </p:sp>
       <p:sp>
         <p:nvSpPr>
-          <p:cNvPr id="141" name="Rectangle 140"/>
+          <p:cNvPr id="143" name="Rectangle 142"/>
           <p:cNvSpPr/>
           <p:nvPr/>
         </p:nvSpPr>
@@ -8921,7 +8987,7 @@
       </p:sp>
       <p:sp>
         <p:nvSpPr>
-          <p:cNvPr id="142" name="TextBox 141"/>
+          <p:cNvPr id="144" name="TextBox 143"/>
           <p:cNvSpPr txBox="1"/>
           <p:nvPr/>
         </p:nvSpPr>
@@ -8963,7 +9029,7 @@
       </p:sp>
       <p:sp>
         <p:nvSpPr>
-          <p:cNvPr id="143" name="TextBox 142"/>
+          <p:cNvPr id="145" name="TextBox 144"/>
           <p:cNvSpPr txBox="1"/>
           <p:nvPr/>
         </p:nvSpPr>
@@ -9005,115 +9071,7 @@
       </p:sp>
       <p:pic>
         <p:nvPicPr>
-          <p:cNvPr id="144" name="Picture 143" descr="r_tta.png"/>
-          <p:cNvPicPr>
-            <a:picLocks noChangeAspect="1"/>
-          </p:cNvPicPr>
-          <p:nvPr/>
-        </p:nvPicPr>
-        <p:blipFill>
-          <a:blip r:embed="rId9"/>
-          <a:stretch>
-            <a:fillRect/>
-          </a:stretch>
-        </p:blipFill>
-        <p:spPr>
-          <a:xfrm>
-            <a:off x="22197060" y="23402656"/>
-            <a:ext cx="9989819" cy="3405620"/>
-          </a:xfrm>
-          <a:prstGeom prst="rect">
-            <a:avLst/>
-          </a:prstGeom>
-        </p:spPr>
-      </p:pic>
-      <p:sp>
-        <p:nvSpPr>
-          <p:cNvPr id="145" name="TextBox 144"/>
-          <p:cNvSpPr txBox="1"/>
-          <p:nvPr/>
-        </p:nvSpPr>
-        <p:spPr>
-          <a:xfrm>
-            <a:off x="22197060" y="26899716"/>
-            <a:ext cx="9989819" cy="365760"/>
-          </a:xfrm>
-          <a:prstGeom prst="rect">
-            <a:avLst/>
-          </a:prstGeom>
-          <a:noFill/>
-        </p:spPr>
-        <p:txBody>
-          <a:bodyPr wrap="square" lIns="0" rIns="0" tIns="0" bIns="0">
-            <a:spAutoFit/>
-          </a:bodyPr>
-          <a:lstStyle/>
-          <a:p>
-            <a:pPr algn="l">
-              <a:lnSpc>
-                <a:spcPct val="120000"/>
-              </a:lnSpc>
-              <a:spcAft>
-                <a:spcPts val="0"/>
-              </a:spcAft>
-            </a:pPr>
-            <a:r>
-              <a:rPr sz="1200" b="0">
-                <a:solidFill>
-                  <a:srgbClr val="556575"/>
-                </a:solidFill>
-                <a:latin typeface="Arial"/>
-              </a:rPr>
-              <a:t>Figure 8.  Test-time compute on the deployable checkpoint. Fusion with no extra views is nothing; multi-scale with h-flip and a 3-seed ensemble are each worth about +0.017 and stack to +0.028. At 2.44 s per image against the deployed 3.7 ms this is a ceiling on what inference-time compute can buy, not a deployment option -- and it is still smaller than the +0.0714 that initialisation is worth.</a:t>
-            </a:r>
-          </a:p>
-        </p:txBody>
-      </p:sp>
-      <p:sp>
-        <p:nvSpPr>
-          <p:cNvPr id="146" name="TextBox 145"/>
-          <p:cNvSpPr txBox="1"/>
-          <p:nvPr/>
-        </p:nvSpPr>
-        <p:spPr>
-          <a:xfrm>
-            <a:off x="11704320" y="27996996"/>
-            <a:ext cx="20482560" cy="365760"/>
-          </a:xfrm>
-          <a:prstGeom prst="rect">
-            <a:avLst/>
-          </a:prstGeom>
-          <a:noFill/>
-        </p:spPr>
-        <p:txBody>
-          <a:bodyPr wrap="square" lIns="0" rIns="0" tIns="0" bIns="0">
-            <a:spAutoFit/>
-          </a:bodyPr>
-          <a:lstStyle/>
-          <a:p>
-            <a:pPr algn="l">
-              <a:lnSpc>
-                <a:spcPct val="100000"/>
-              </a:lnSpc>
-              <a:spcAft>
-                <a:spcPts val="0"/>
-              </a:spcAft>
-            </a:pPr>
-            <a:r>
-              <a:rPr sz="1800" b="1">
-                <a:solidFill>
-                  <a:srgbClr val="1E293B"/>
-                </a:solidFill>
-                <a:latin typeface="Arial"/>
-              </a:rPr>
-              <a:t>Why the loop looked like it was learning</a:t>
-            </a:r>
-          </a:p>
-        </p:txBody>
-      </p:sp>
-      <p:pic>
-        <p:nvPicPr>
-          <p:cNvPr id="147" name="Picture 146" descr="f_rounds.png"/>
+          <p:cNvPr id="146" name="Picture 145" descr="r_tta.png"/>
           <p:cNvPicPr>
             <a:picLocks noChangeAspect="1"/>
           </p:cNvPicPr>
@@ -9127,7 +9085,115 @@
         </p:blipFill>
         <p:spPr>
           <a:xfrm>
-            <a:off x="11704320" y="28307892"/>
+            <a:off x="22197060" y="23402656"/>
+            <a:ext cx="9989819" cy="3348860"/>
+          </a:xfrm>
+          <a:prstGeom prst="rect">
+            <a:avLst/>
+          </a:prstGeom>
+        </p:spPr>
+      </p:pic>
+      <p:sp>
+        <p:nvSpPr>
+          <p:cNvPr id="147" name="TextBox 146"/>
+          <p:cNvSpPr txBox="1"/>
+          <p:nvPr/>
+        </p:nvSpPr>
+        <p:spPr>
+          <a:xfrm>
+            <a:off x="22197060" y="26842956"/>
+            <a:ext cx="9989819" cy="365760"/>
+          </a:xfrm>
+          <a:prstGeom prst="rect">
+            <a:avLst/>
+          </a:prstGeom>
+          <a:noFill/>
+        </p:spPr>
+        <p:txBody>
+          <a:bodyPr wrap="square" lIns="0" rIns="0" tIns="0" bIns="0">
+            <a:spAutoFit/>
+          </a:bodyPr>
+          <a:lstStyle/>
+          <a:p>
+            <a:pPr algn="l">
+              <a:lnSpc>
+                <a:spcPct val="120000"/>
+              </a:lnSpc>
+              <a:spcAft>
+                <a:spcPts val="0"/>
+              </a:spcAft>
+            </a:pPr>
+            <a:r>
+              <a:rPr sz="1200" b="0">
+                <a:solidFill>
+                  <a:srgbClr val="556575"/>
+                </a:solidFill>
+                <a:latin typeface="Arial"/>
+              </a:rPr>
+              <a:t>Figure 9.  Test-time compute on the deployable checkpoint. Fusion with no extra views is nothing; multi-scale with h-flip and a 3-seed ensemble are each worth about +0.017 and stack to +0.028. At 2.44 s per image against the deployed 3.7 ms this is a ceiling on what inference-time compute can buy, not a deployment option -- and it is still smaller than the +0.0714 that initialisation is worth.</a:t>
+            </a:r>
+          </a:p>
+        </p:txBody>
+      </p:sp>
+      <p:sp>
+        <p:nvSpPr>
+          <p:cNvPr id="148" name="TextBox 147"/>
+          <p:cNvSpPr txBox="1"/>
+          <p:nvPr/>
+        </p:nvSpPr>
+        <p:spPr>
+          <a:xfrm>
+            <a:off x="11704320" y="27940236"/>
+            <a:ext cx="20482560" cy="365760"/>
+          </a:xfrm>
+          <a:prstGeom prst="rect">
+            <a:avLst/>
+          </a:prstGeom>
+          <a:noFill/>
+        </p:spPr>
+        <p:txBody>
+          <a:bodyPr wrap="square" lIns="0" rIns="0" tIns="0" bIns="0">
+            <a:spAutoFit/>
+          </a:bodyPr>
+          <a:lstStyle/>
+          <a:p>
+            <a:pPr algn="l">
+              <a:lnSpc>
+                <a:spcPct val="100000"/>
+              </a:lnSpc>
+              <a:spcAft>
+                <a:spcPts val="0"/>
+              </a:spcAft>
+            </a:pPr>
+            <a:r>
+              <a:rPr sz="1800" b="1">
+                <a:solidFill>
+                  <a:srgbClr val="1E293B"/>
+                </a:solidFill>
+                <a:latin typeface="Arial"/>
+              </a:rPr>
+              <a:t>Why the loop looked like it was learning</a:t>
+            </a:r>
+          </a:p>
+        </p:txBody>
+      </p:sp>
+      <p:pic>
+        <p:nvPicPr>
+          <p:cNvPr id="149" name="Picture 148" descr="f_rounds.png"/>
+          <p:cNvPicPr>
+            <a:picLocks noChangeAspect="1"/>
+          </p:cNvPicPr>
+          <p:nvPr/>
+        </p:nvPicPr>
+        <p:blipFill>
+          <a:blip r:embed="rId11"/>
+          <a:stretch>
+            <a:fillRect/>
+          </a:stretch>
+        </p:blipFill>
+        <p:spPr>
+          <a:xfrm>
+            <a:off x="11704320" y="28251132"/>
             <a:ext cx="20482560" cy="3749135"/>
           </a:xfrm>
           <a:prstGeom prst="rect">
@@ -9137,13 +9203,13 @@
       </p:pic>
       <p:sp>
         <p:nvSpPr>
-          <p:cNvPr id="148" name="TextBox 147"/>
-          <p:cNvSpPr txBox="1"/>
-          <p:nvPr/>
-        </p:nvSpPr>
-        <p:spPr>
-          <a:xfrm>
-            <a:off x="11704320" y="32148467"/>
+          <p:cNvPr id="150" name="TextBox 149"/>
+          <p:cNvSpPr txBox="1"/>
+          <p:nvPr/>
+        </p:nvSpPr>
+        <p:spPr>
+          <a:xfrm>
+            <a:off x="11704320" y="32091707"/>
             <a:ext cx="20482560" cy="365760"/>
           </a:xfrm>
           <a:prstGeom prst="rect">
@@ -9172,14 +9238,14 @@
                 </a:solidFill>
                 <a:latin typeface="Arial"/>
               </a:rPr>
-              <a:t>Figure 9.  (f) Fifteen unattended rounds on a fixed holdout. (g) Round 15's exact dataset, three ways. Bars 1 and 2 differ only in the starting weights, so their gap is the warm-start chain; bar 3 is the recipe the campaign ran, whose wall-clock cap truncates the cosine. Sigma throughout is that recipe's own seed spread, 0.0040 over three seeds, propagated to the difference being quoted. Completing the schedule is not the fix -- bar 2 sits below bar 3.</a:t>
-            </a:r>
-          </a:p>
-        </p:txBody>
-      </p:sp>
-      <p:sp>
-        <p:nvSpPr>
-          <p:cNvPr id="149" name="TextBox 148"/>
+              <a:t>Figure 10.  (f) Fifteen unattended rounds on a fixed holdout. (g) Round 15's exact dataset, three ways. Bars 1 and 2 differ only in the starting weights, so their gap is the warm-start chain; bar 3 is the recipe the campaign ran, whose wall-clock cap truncates the cosine. Sigma throughout is that recipe's own seed spread, 0.0040 over three seeds, propagated to the difference being quoted. Completing the schedule is not the fix -- bar 2 sits below bar 3.</a:t>
+            </a:r>
+          </a:p>
+        </p:txBody>
+      </p:sp>
+      <p:sp>
+        <p:nvSpPr>
+          <p:cNvPr id="151" name="TextBox 150"/>
           <p:cNvSpPr txBox="1"/>
           <p:nvPr/>
         </p:nvSpPr>
@@ -9221,7 +9287,7 @@
       </p:sp>
       <p:sp>
         <p:nvSpPr>
-          <p:cNvPr id="150" name="Rectangle 149"/>
+          <p:cNvPr id="152" name="Rectangle 151"/>
           <p:cNvSpPr/>
           <p:nvPr/>
         </p:nvSpPr>
@@ -9265,73 +9331,7 @@
       </p:sp>
       <p:pic>
         <p:nvPicPr>
-          <p:cNvPr id="151" name="Picture 150" descr="d_wall.png"/>
-          <p:cNvPicPr>
-            <a:picLocks noChangeAspect="1"/>
-          </p:cNvPicPr>
-          <p:nvPr/>
-        </p:nvPicPr>
-        <p:blipFill>
-          <a:blip r:embed="rId11"/>
-          <a:stretch>
-            <a:fillRect/>
-          </a:stretch>
-        </p:blipFill>
-        <p:spPr>
-          <a:xfrm>
-            <a:off x="32552640" y="5577840"/>
-            <a:ext cx="10607040" cy="6362678"/>
-          </a:xfrm>
-          <a:prstGeom prst="rect">
-            <a:avLst/>
-          </a:prstGeom>
-        </p:spPr>
-      </p:pic>
-      <p:sp>
-        <p:nvSpPr>
-          <p:cNvPr id="152" name="TextBox 151"/>
-          <p:cNvSpPr txBox="1"/>
-          <p:nvPr/>
-        </p:nvSpPr>
-        <p:spPr>
-          <a:xfrm>
-            <a:off x="32552640" y="12031958"/>
-            <a:ext cx="10607040" cy="365760"/>
-          </a:xfrm>
-          <a:prstGeom prst="rect">
-            <a:avLst/>
-          </a:prstGeom>
-          <a:noFill/>
-        </p:spPr>
-        <p:txBody>
-          <a:bodyPr wrap="square" lIns="0" rIns="0" tIns="0" bIns="0">
-            <a:spAutoFit/>
-          </a:bodyPr>
-          <a:lstStyle/>
-          <a:p>
-            <a:pPr algn="l">
-              <a:lnSpc>
-                <a:spcPct val="120000"/>
-              </a:lnSpc>
-              <a:spcAft>
-                <a:spcPts val="0"/>
-              </a:spcAft>
-            </a:pPr>
-            <a:r>
-              <a:rPr sz="1200" b="0">
-                <a:solidFill>
-                  <a:srgbClr val="556575"/>
-                </a:solidFill>
-                <a:latin typeface="Arial"/>
-              </a:rPr>
-              <a:t>Figure 10.  The same three checkpoints and the same matcher on both sides, so the evaluator offset cancels. A detector trained on one field does not transfer to another.</a:t>
-            </a:r>
-          </a:p>
-        </p:txBody>
-      </p:sp>
-      <p:pic>
-        <p:nvPicPr>
-          <p:cNvPr id="153" name="Picture 152" descr="p_field.png"/>
+          <p:cNvPr id="153" name="Picture 152" descr="d_wall.png"/>
           <p:cNvPicPr>
             <a:picLocks noChangeAspect="1"/>
           </p:cNvPicPr>
@@ -9345,8 +9345,8 @@
         </p:blipFill>
         <p:spPr>
           <a:xfrm>
-            <a:off x="32552640" y="12672038"/>
-            <a:ext cx="10607040" cy="5360041"/>
+            <a:off x="32552640" y="5577840"/>
+            <a:ext cx="10607040" cy="6362678"/>
           </a:xfrm>
           <a:prstGeom prst="rect">
             <a:avLst/>
@@ -9361,7 +9361,7 @@
         </p:nvSpPr>
         <p:spPr>
           <a:xfrm>
-            <a:off x="32552640" y="18123519"/>
+            <a:off x="32552640" y="12031958"/>
             <a:ext cx="10607040" cy="365760"/>
           </a:xfrm>
           <a:prstGeom prst="rect">
@@ -9390,14 +9390,14 @@
                 </a:solidFill>
                 <a:latin typeface="Arial"/>
               </a:rPr>
-              <a:t>Figure 11.  The deployable checkpoint over every frame the two robots recorded, at the confidence the cart deploys at. There is no ground truth for these frames, so this is the rate at which the detector produces a box at all -- not recall and not precision. Vegetation is excess green over a thumbnail, so "nothing to detect" does not account for it: 1157 frames clear that bar and 21 of them draw a box. 24 of the 25 boxes it does draw are the same class.</a:t>
+              <a:t>Figure 11.  The same three checkpoints and the same matcher on both sides, so the evaluator offset cancels. A detector trained on one field does not transfer to another.</a:t>
             </a:r>
           </a:p>
         </p:txBody>
       </p:sp>
       <p:pic>
         <p:nvPicPr>
-          <p:cNvPr id="155" name="Picture 154" descr="j_species.png"/>
+          <p:cNvPr id="155" name="Picture 154" descr="p_field.png"/>
           <p:cNvPicPr>
             <a:picLocks noChangeAspect="1"/>
           </p:cNvPicPr>
@@ -9411,6 +9411,72 @@
         </p:blipFill>
         <p:spPr>
           <a:xfrm>
+            <a:off x="32552640" y="12672038"/>
+            <a:ext cx="10607040" cy="5360041"/>
+          </a:xfrm>
+          <a:prstGeom prst="rect">
+            <a:avLst/>
+          </a:prstGeom>
+        </p:spPr>
+      </p:pic>
+      <p:sp>
+        <p:nvSpPr>
+          <p:cNvPr id="156" name="TextBox 155"/>
+          <p:cNvSpPr txBox="1"/>
+          <p:nvPr/>
+        </p:nvSpPr>
+        <p:spPr>
+          <a:xfrm>
+            <a:off x="32552640" y="18123519"/>
+            <a:ext cx="10607040" cy="365760"/>
+          </a:xfrm>
+          <a:prstGeom prst="rect">
+            <a:avLst/>
+          </a:prstGeom>
+          <a:noFill/>
+        </p:spPr>
+        <p:txBody>
+          <a:bodyPr wrap="square" lIns="0" rIns="0" tIns="0" bIns="0">
+            <a:spAutoFit/>
+          </a:bodyPr>
+          <a:lstStyle/>
+          <a:p>
+            <a:pPr algn="l">
+              <a:lnSpc>
+                <a:spcPct val="120000"/>
+              </a:lnSpc>
+              <a:spcAft>
+                <a:spcPts val="0"/>
+              </a:spcAft>
+            </a:pPr>
+            <a:r>
+              <a:rPr sz="1200" b="0">
+                <a:solidFill>
+                  <a:srgbClr val="556575"/>
+                </a:solidFill>
+                <a:latin typeface="Arial"/>
+              </a:rPr>
+              <a:t>Figure 12.  The deployable checkpoint over every frame the two robots recorded, at the confidence the cart deploys at. There is no ground truth for these frames, so this is the rate at which the detector produces a box at all -- not recall and not precision. Vegetation is excess green over a thumbnail, so "nothing to detect" does not account for it: 1157 frames clear that bar and 21 of them draw a box. 24 of the 25 boxes it does draw are the same class.</a:t>
+            </a:r>
+          </a:p>
+        </p:txBody>
+      </p:sp>
+      <p:pic>
+        <p:nvPicPr>
+          <p:cNvPr id="157" name="Picture 156" descr="j_species.png"/>
+          <p:cNvPicPr>
+            <a:picLocks noChangeAspect="1"/>
+          </p:cNvPicPr>
+          <p:nvPr/>
+        </p:nvPicPr>
+        <p:blipFill>
+          <a:blip r:embed="rId14"/>
+          <a:stretch>
+            <a:fillRect/>
+          </a:stretch>
+        </p:blipFill>
+        <p:spPr>
+          <a:xfrm>
             <a:off x="32552640" y="19129359"/>
             <a:ext cx="10607040" cy="5429067"/>
           </a:xfrm>
@@ -9421,7 +9487,7 @@
       </p:pic>
       <p:sp>
         <p:nvSpPr>
-          <p:cNvPr id="156" name="TextBox 155"/>
+          <p:cNvPr id="158" name="TextBox 157"/>
           <p:cNvSpPr txBox="1"/>
           <p:nvPr/>
         </p:nvSpPr>
@@ -9456,14 +9522,14 @@
                 </a:solidFill>
                 <a:latin typeface="Arial"/>
               </a:rPr>
-              <a:t>Figure 12.  Per-species performance of the deployable checkpoint. The spread across the twelve classes is 0.214, roughly seventy times the seed noise.</a:t>
-            </a:r>
-          </a:p>
-        </p:txBody>
-      </p:sp>
-      <p:sp>
-        <p:nvSpPr>
-          <p:cNvPr id="157" name="TextBox 156"/>
+              <a:t>Figure 13.  Per-species performance of the deployable checkpoint. The spread across the twelve classes is 0.214, roughly seventy times the seed noise.</a:t>
+            </a:r>
+          </a:p>
+        </p:txBody>
+      </p:sp>
+      <p:sp>
+        <p:nvSpPr>
+          <p:cNvPr id="159" name="TextBox 158"/>
           <p:cNvSpPr txBox="1"/>
           <p:nvPr/>
         </p:nvSpPr>
@@ -9505,7 +9571,7 @@
       </p:sp>
       <p:sp>
         <p:nvSpPr>
-          <p:cNvPr id="158" name="Rectangle 157"/>
+          <p:cNvPr id="160" name="Rectangle 159"/>
           <p:cNvSpPr/>
           <p:nvPr/>
         </p:nvSpPr>
@@ -9549,7 +9615,7 @@
       </p:sp>
       <p:sp>
         <p:nvSpPr>
-          <p:cNvPr id="159" name="TextBox 158"/>
+          <p:cNvPr id="161" name="TextBox 160"/>
           <p:cNvSpPr txBox="1"/>
           <p:nvPr/>
         </p:nvSpPr>
@@ -9591,7 +9657,7 @@
       </p:sp>
       <p:sp>
         <p:nvSpPr>
-          <p:cNvPr id="160" name="TextBox 159"/>
+          <p:cNvPr id="162" name="TextBox 161"/>
           <p:cNvSpPr txBox="1"/>
           <p:nvPr/>
         </p:nvSpPr>
@@ -9633,7 +9699,7 @@
       </p:sp>
       <p:sp>
         <p:nvSpPr>
-          <p:cNvPr id="161" name="TextBox 160"/>
+          <p:cNvPr id="163" name="TextBox 162"/>
           <p:cNvSpPr txBox="1"/>
           <p:nvPr/>
         </p:nvSpPr>
@@ -9675,7 +9741,7 @@
       </p:sp>
       <p:sp>
         <p:nvSpPr>
-          <p:cNvPr id="162" name="TextBox 161"/>
+          <p:cNvPr id="164" name="TextBox 163"/>
           <p:cNvSpPr txBox="1"/>
           <p:nvPr/>
         </p:nvSpPr>
@@ -9717,7 +9783,7 @@
       </p:sp>
       <p:sp>
         <p:nvSpPr>
-          <p:cNvPr id="163" name="TextBox 162"/>
+          <p:cNvPr id="165" name="TextBox 164"/>
           <p:cNvSpPr txBox="1"/>
           <p:nvPr/>
         </p:nvSpPr>
@@ -9759,7 +9825,7 @@
       </p:sp>
       <p:sp>
         <p:nvSpPr>
-          <p:cNvPr id="164" name="TextBox 163"/>
+          <p:cNvPr id="166" name="TextBox 165"/>
           <p:cNvSpPr txBox="1"/>
           <p:nvPr/>
         </p:nvSpPr>
@@ -9801,7 +9867,7 @@
       </p:sp>
       <p:sp>
         <p:nvSpPr>
-          <p:cNvPr id="165" name="TextBox 164"/>
+          <p:cNvPr id="167" name="TextBox 166"/>
           <p:cNvSpPr txBox="1"/>
           <p:nvPr/>
         </p:nvSpPr>
@@ -9843,7 +9909,7 @@
       </p:sp>
       <p:sp>
         <p:nvSpPr>
-          <p:cNvPr id="166" name="Rectangle 165"/>
+          <p:cNvPr id="168" name="Rectangle 167"/>
           <p:cNvSpPr/>
           <p:nvPr/>
         </p:nvSpPr>
@@ -9887,7 +9953,7 @@
       </p:sp>
       <p:sp>
         <p:nvSpPr>
-          <p:cNvPr id="167" name="TextBox 166"/>
+          <p:cNvPr id="169" name="TextBox 168"/>
           <p:cNvSpPr txBox="1"/>
           <p:nvPr/>
         </p:nvSpPr>
@@ -9929,7 +9995,7 @@
       </p:sp>
       <p:sp>
         <p:nvSpPr>
-          <p:cNvPr id="168" name="TextBox 167"/>
+          <p:cNvPr id="170" name="TextBox 169"/>
           <p:cNvSpPr txBox="1"/>
           <p:nvPr/>
         </p:nvSpPr>
@@ -9971,7 +10037,7 @@
       </p:sp>
       <p:sp>
         <p:nvSpPr>
-          <p:cNvPr id="169" name="Rectangle 168"/>
+          <p:cNvPr id="171" name="Rectangle 170"/>
           <p:cNvSpPr/>
           <p:nvPr/>
         </p:nvSpPr>
@@ -10015,7 +10081,7 @@
       </p:sp>
       <p:sp>
         <p:nvSpPr>
-          <p:cNvPr id="170" name="TextBox 169"/>
+          <p:cNvPr id="172" name="TextBox 171"/>
           <p:cNvSpPr txBox="1"/>
           <p:nvPr/>
         </p:nvSpPr>

</xml_diff>

<commit_message>
poster: two authors, one department
Song Cui was on an earlier draft and is not an author of this work. The
author line is Harry He and Hongbo Zhang, Department of Engineering
Technology, Middle Tennessee State University -- no second affiliation and
no superscripts, since there is only one.

The affiliation line is now built from poster_data rather than hardcoded in
build.py, so the two cannot disagree again.

Co-Authored-By: Claude Opus 5 (1M context) <noreply@anthropic.com>
Claude-Session: https://claude.ai/code/session_019GW1g5v3nTp9QATBzJYkkw
</commit_message>
<xml_diff>
--- a/docs/poster/MTSU_WeedAgent_Poster.pptx
+++ b/docs/poster/MTSU_WeedAgent_Poster.pptx
@@ -3247,7 +3247,7 @@
                 </a:solidFill>
                 <a:latin typeface="Arial"/>
               </a:rPr>
-              <a:t>Hongbo Zhang</a:t>
+              <a:t>Harry He</a:t>
             </a:r>
             <a:r>
               <a:rPr sz="2000" b="1" baseline="30000">
@@ -3256,7 +3256,7 @@
                 </a:solidFill>
                 <a:latin typeface="Arial"/>
               </a:rPr>
-              <a:t>1</a:t>
+              <a:t/>
             </a:r>
             <a:r>
               <a:rPr sz="3200" b="1">
@@ -3265,7 +3265,7 @@
                 </a:solidFill>
                 <a:latin typeface="Arial"/>
               </a:rPr>
-              <a:t>,     Harry He</a:t>
+              <a:t>,     Hongbo Zhang</a:t>
             </a:r>
             <a:r>
               <a:rPr sz="2000" b="1" baseline="30000">
@@ -3274,25 +3274,7 @@
                 </a:solidFill>
                 <a:latin typeface="Arial"/>
               </a:rPr>
-              <a:t>1</a:t>
-            </a:r>
-            <a:r>
-              <a:rPr sz="3200" b="1">
-                <a:solidFill>
-                  <a:srgbClr val="FFFFFF"/>
-                </a:solidFill>
-                <a:latin typeface="Arial"/>
-              </a:rPr>
-              <a:t>,     Song Cui</a:t>
-            </a:r>
-            <a:r>
-              <a:rPr sz="2000" b="1" baseline="30000">
-                <a:solidFill>
-                  <a:srgbClr val="FFFFFF"/>
-                </a:solidFill>
-                <a:latin typeface="Arial"/>
-              </a:rPr>
-              <a:t>2</a:t>
+              <a:t/>
             </a:r>
           </a:p>
         </p:txBody>
@@ -3334,7 +3316,7 @@
                 </a:solidFill>
                 <a:latin typeface="Arial"/>
               </a:rPr>
-              <a:t>¹Department of Engineering Technology   ·   ²School of Agriculture   ·   Middle Tennessee State University, Murfreesboro, TN, USA</a:t>
+              <a:t>Department of Engineering Technology   ·   Middle Tennessee State University, Murfreesboro, TN, USA</a:t>
             </a:r>
           </a:p>
         </p:txBody>

</xml_diff>